<commit_message>
docs: update all financial figures to Indian Rupees (INR)
</commit_message>
<xml_diff>
--- a/VybeAI_WorkplaceWellnessAgent/VybeAI_WorkplaceWellnessAgent_Presentation.pptx
+++ b/VybeAI_WorkplaceWellnessAgent/VybeAI_WorkplaceWellnessAgent_Presentation.pptx
@@ -6983,7 +6983,7 @@
                   <a:srgbClr val="14213D"/>
                 </a:solidFill>
               </a:rPr>
-              <a:t>• $50B+ Annual Cost: </a:t>
+              <a:t>• ₹4.15 Lakh Cr ($50B+) Cost: </a:t>
             </a:r>
             <a:r>
               <a:rPr sz="1100">
@@ -6991,7 +6991,7 @@
                   <a:srgbClr val="475569"/>
                 </a:solidFill>
               </a:rPr>
-              <a:t>Musculoskeletal disorders account for over $50B in direct corporate healthcare and compensation claims.</a:t>
+              <a:t>Musculoskeletal disorders account for over ₹4.15 Lakh Crore in direct corporate healthcare and compensation claims.</a:t>
             </a:r>
           </a:p>
           <a:p>
@@ -9381,7 +9381,7 @@
               </a:defRPr>
             </a:pPr>
             <a:r>
-              <a:t>$1,800 Saved / Employee</a:t>
+              <a:t>₹1,50,000 Saved / Employee</a:t>
             </a:r>
           </a:p>
           <a:p>
@@ -9393,7 +9393,7 @@
               </a:defRPr>
             </a:pPr>
             <a:r>
-              <a:t>Significantly lowers musculoskeletal disorder (MSD) insurance claims, ergonomic physical therapy costs, and repetitive strain injury (RSI) compensations.</a:t>
+              <a:t>Significantly lowers musculoskeletal disorder (MSD) insurance claims, ergonomic physical therapy costs, and repetitive strain injury (RSI) compensations annually.</a:t>
             </a:r>
           </a:p>
         </p:txBody>
@@ -9477,7 +9477,7 @@
               </a:defRPr>
             </a:pPr>
             <a:r>
-              <a:t>Decreases technical developer churn caused by relentless sprints and exhaustion. Retaining a single senior software engineer saves $50,000+ in recruiting.</a:t>
+              <a:t>Decreases technical developer churn caused by relentless sprints. Retaining a single senior software engineer saves ₹40,00,000+ ($50k) in recruitment costs.</a:t>
             </a:r>
           </a:p>
         </p:txBody>
@@ -10494,7 +10494,7 @@
                   <a:srgbClr val="475569"/>
                 </a:solidFill>
               </a:rPr>
-              <a:t>$1,500 – $2,500: Ergonomic activity library creation, wireframes, and branding.</a:t>
+              <a:t>₹1,25,000 – ₹2,00,000: Ergonomic activity library creation, wireframes, and branding.</a:t>
             </a:r>
           </a:p>
           <a:p>
@@ -10517,7 +10517,7 @@
                   <a:srgbClr val="475569"/>
                 </a:solidFill>
               </a:rPr>
-              <a:t>$2,500 – $3,500: React 18, Web Workers, Web Audio synthesizer, and Recharts.</a:t>
+              <a:t>₹2,00,000 – ₹3,00,000: React 18, Web Workers, Web Audio synthesizer, and Recharts.</a:t>
             </a:r>
           </a:p>
           <a:p>
@@ -10540,7 +10540,7 @@
                   <a:srgbClr val="475569"/>
                 </a:solidFill>
               </a:rPr>
-              <a:t>$2,000 – $3,000: FastAPI, SQLite, Gemini structured schema, and Windows daemon.</a:t>
+              <a:t>₹1,65,000 – ₹2,50,000: FastAPI, SQLite, Gemini structured schema, and Windows daemon.</a:t>
             </a:r>
           </a:p>
           <a:p>
@@ -10563,7 +10563,7 @@
                   <a:srgbClr val="475569"/>
                 </a:solidFill>
               </a:rPr>
-              <a:t>$1,000 – $1,500: Automated test suite (27 unit/integration tests) and deployment.</a:t>
+              <a:t>₹80,000 – ₹1,25,000: Automated test suite (27 unit/integration tests) and deployment.</a:t>
             </a:r>
           </a:p>
           <a:p>
@@ -10586,7 +10586,7 @@
                   <a:srgbClr val="475569"/>
                 </a:solidFill>
               </a:rPr>
-              <a:t>$7,000 – $10,500 (Can be completed in a 3-week agile engineering sprint).</a:t>
+              <a:t>₹5,80,000 – ₹8,75,000 (~₹6 – ₹8.5 Lakhs in a 3-week agile engineering sprint).</a:t>
             </a:r>
           </a:p>
         </p:txBody>
@@ -10666,7 +10666,7 @@
                   <a:srgbClr val="475569"/>
                 </a:solidFill>
               </a:rPr>
-              <a:t>$20 / month: Unlimited bandwidth, global edge distribution, and automated CI/CD.</a:t>
+              <a:t>₹1,650 / month ($20/mo): Unlimited bandwidth, global edge distribution &amp; CI/CD.</a:t>
             </a:r>
           </a:p>
           <a:p>
@@ -10689,7 +10689,7 @@
                   <a:srgbClr val="475569"/>
                 </a:solidFill>
               </a:rPr>
-              <a:t>$0 – $15 / month: Lightweight embedded storage with negligible I/O costs.</a:t>
+              <a:t>₹0 – ₹1,200 / month: Lightweight embedded storage with negligible I/O costs.</a:t>
             </a:r>
           </a:p>
           <a:p>
@@ -10712,7 +10712,7 @@
                   <a:srgbClr val="475569"/>
                 </a:solidFill>
               </a:rPr>
-              <a:t>$10 – $25 / month: Edge fallback resolves 85% of queries locally at $0 cost.</a:t>
+              <a:t>₹800 – ₹2,000 / month: Edge fallback resolves 85% of queries locally at ₹0 cost.</a:t>
             </a:r>
           </a:p>
           <a:p>
@@ -10735,7 +10735,7 @@
                   <a:srgbClr val="475569"/>
                 </a:solidFill>
               </a:rPr>
-              <a:t>$100 / month: Routine updates and dependency audits.</a:t>
+              <a:t>₹8,000 / month: Routine updates, monitoring, and dependency audits.</a:t>
             </a:r>
           </a:p>
           <a:p>
@@ -10758,7 +10758,7 @@
                   <a:srgbClr val="475569"/>
                 </a:solidFill>
               </a:rPr>
-              <a:t>~$150 / month across 1,000 active employees (&lt;$0.15 / user / month!).</a:t>
+              <a:t>~₹12,500 / month across 1,000 active employees (&lt;₹12.50 / employee / month!).</a:t>
             </a:r>
           </a:p>
         </p:txBody>

</xml_diff>